<commit_message>
docs: narrow chapter scope and quantify scale and failure costs
</commit_message>
<xml_diff>
--- a/第六章_核心流程图_可编辑源文件.pptx
+++ b/第六章_核心流程图_可编辑源文件.pptx
@@ -8121,7 +8121,7 @@
                 <a:ea typeface="Arial Unicode MS" pitchFamily="34" charset="-122"/>
                 <a:cs typeface="Arial Unicode MS" pitchFamily="34" charset="-120"/>
               </a:rPr>
-              <a:t>图 6.9　AI 辅助链上研究的八步流程与停止关口</a:t>
+              <a:t>图 6.9　链上价差候选的八项终检与停止关口</a:t>
             </a:r>
             <a:endParaRPr lang="en-US" sz="2300" dirty="0"/>
           </a:p>
@@ -8258,7 +8258,7 @@
                 <a:ea typeface="Arial Unicode MS" pitchFamily="34" charset="-122"/>
                 <a:cs typeface="Arial Unicode MS" pitchFamily="34" charset="-120"/>
               </a:rPr>
-              <a:t>1 定义对象 时点 规模与终态</a:t>
+              <a:t>1 合约与 Chain ID 一致</a:t>
             </a:r>
             <a:endParaRPr lang="en-US" sz="1000" dirty="0"/>
           </a:p>
@@ -8326,7 +8326,7 @@
                 <a:ea typeface="Arial Unicode MS" pitchFamily="34" charset="-122"/>
                 <a:cs typeface="Arial Unicode MS" pitchFamily="34" charset="-120"/>
               </a:rPr>
-              <a:t>2 核验资产身份</a:t>
+              <a:t>2 前置状态与区块一致</a:t>
             </a:r>
             <a:endParaRPr lang="en-US" sz="1000" dirty="0"/>
           </a:p>
@@ -8394,7 +8394,7 @@
                 <a:ea typeface="Arial Unicode MS" pitchFamily="34" charset="-122"/>
                 <a:cs typeface="Arial Unicode MS" pitchFamily="34" charset="-120"/>
               </a:rPr>
-              <a:t>3 建立价格锚表</a:t>
+              <a:t>3 Quote 仍在有效窗口</a:t>
             </a:r>
             <a:endParaRPr lang="en-US" sz="1000" dirty="0"/>
           </a:p>
@@ -8462,7 +8462,7 @@
                 <a:ea typeface="Arial Unicode MS" pitchFamily="34" charset="-122"/>
                 <a:cs typeface="Arial Unicode MS" pitchFamily="34" charset="-120"/>
               </a:rPr>
-              <a:t>4 绘制市场图谱</a:t>
+              <a:t>4 输出与成本没有重复计算</a:t>
             </a:r>
             <a:endParaRPr lang="en-US" sz="1000" dirty="0"/>
           </a:p>
@@ -8530,7 +8530,7 @@
                 <a:ea typeface="Arial Unicode MS" pitchFamily="34" charset="-122"/>
                 <a:cs typeface="Arial Unicode MS" pitchFamily="34" charset="-120"/>
               </a:rPr>
-              <a:t>5 获取同口径 Quote 与快照</a:t>
+              <a:t>5 赎回与账户资格存在</a:t>
             </a:r>
             <a:endParaRPr lang="en-US" sz="1000" dirty="0"/>
           </a:p>
@@ -8598,7 +8598,7 @@
                 <a:ea typeface="Arial Unicode MS" pitchFamily="34" charset="-122"/>
                 <a:cs typeface="Arial Unicode MS" pitchFamily="34" charset="-120"/>
               </a:rPr>
-              <a:t>6 计算完整周期损益与压力情景</a:t>
+              <a:t>6 指定规模保留收益余量</a:t>
             </a:r>
             <a:endParaRPr lang="en-US" sz="1000" dirty="0"/>
           </a:p>
@@ -8666,7 +8666,7 @@
                 <a:ea typeface="Arial Unicode MS" pitchFamily="34" charset="-122"/>
                 <a:cs typeface="Arial Unicode MS" pitchFamily="34" charset="-120"/>
               </a:rPr>
-              <a:t>7 核验来源并寻找反证</a:t>
+              <a:t>7 失败资金位置与损失清楚</a:t>
             </a:r>
             <a:endParaRPr lang="en-US" sz="1000" dirty="0"/>
           </a:p>
@@ -8734,7 +8734,7 @@
                 <a:ea typeface="Arial Unicode MS" pitchFamily="34" charset="-122"/>
                 <a:cs typeface="Arial Unicode MS" pitchFamily="34" charset="-120"/>
               </a:rPr>
-              <a:t>8 输出证据包与结论等级</a:t>
+              <a:t>8 判断是否值得继续研究</a:t>
             </a:r>
             <a:endParaRPr lang="en-US" sz="1000" dirty="0"/>
           </a:p>
@@ -9025,17 +9025,13 @@
         </p:nvSpPr>
         <p:spPr>
           <a:xfrm>
-            <a:off x="5441362" y="2097411"/>
-            <a:ext cx="1324856" cy="282440"/>
-          </a:xfrm>
-          <a:prstGeom prst="rect">
-            <a:avLst/>
-          </a:prstGeom>
-          <a:solidFill>
-            <a:srgbClr val="FFFFFF">
-              <a:alpha val="92000"/>
-            </a:srgbClr>
-          </a:solidFill>
+            <a:off x="5669280" y="1453896"/>
+            <a:ext cx="960120" cy="282440"/>
+          </a:xfrm>
+          <a:prstGeom prst="rect">
+            <a:avLst/>
+          </a:prstGeom>
+          <a:noFill/>
           <a:ln/>
         </p:spPr>
         <p:txBody>
@@ -9056,7 +9052,7 @@
                 <a:ea typeface="Arial Unicode MS" pitchFamily="34" charset="-122"/>
                 <a:cs typeface="Arial Unicode MS" pitchFamily="34" charset="-120"/>
               </a:rPr>
-              <a:t>身份不明</a:t>
+              <a:t>前置状态不明</a:t>
             </a:r>
             <a:endParaRPr lang="en-US" sz="900" dirty="0"/>
           </a:p>
@@ -9094,17 +9090,13 @@
         </p:nvSpPr>
         <p:spPr>
           <a:xfrm>
-            <a:off x="5441362" y="2524601"/>
-            <a:ext cx="1324856" cy="282440"/>
-          </a:xfrm>
-          <a:prstGeom prst="rect">
-            <a:avLst/>
-          </a:prstGeom>
-          <a:solidFill>
-            <a:srgbClr val="FFFFFF">
-              <a:alpha val="92000"/>
-            </a:srgbClr>
-          </a:solidFill>
+            <a:off x="5669280" y="2286000"/>
+            <a:ext cx="960120" cy="282440"/>
+          </a:xfrm>
+          <a:prstGeom prst="rect">
+            <a:avLst/>
+          </a:prstGeom>
+          <a:noFill/>
           <a:ln/>
         </p:spPr>
         <p:txBody>
@@ -9125,7 +9117,7 @@
                 <a:ea typeface="Arial Unicode MS" pitchFamily="34" charset="-122"/>
                 <a:cs typeface="Arial Unicode MS" pitchFamily="34" charset="-120"/>
               </a:rPr>
-              <a:t>路径缺边</a:t>
+              <a:t>费用口径不清</a:t>
             </a:r>
             <a:endParaRPr lang="en-US" sz="900" dirty="0"/>
           </a:p>
@@ -9138,9 +9130,9 @@
           <p:nvPr/>
         </p:nvSpPr>
         <p:spPr>
-          <a:xfrm>
-            <a:off x="5648371" y="3416936"/>
-            <a:ext cx="910839" cy="-647847"/>
+          <a:xfrm flipV="1">
+            <a:off x="5648371" y="2769089"/>
+            <a:ext cx="910839" cy="647847"/>
           </a:xfrm>
           <a:prstGeom prst="line">
             <a:avLst/>
@@ -9163,17 +9155,13 @@
         </p:nvSpPr>
         <p:spPr>
           <a:xfrm>
-            <a:off x="5441362" y="2951792"/>
-            <a:ext cx="1324856" cy="282440"/>
-          </a:xfrm>
-          <a:prstGeom prst="rect">
-            <a:avLst/>
-          </a:prstGeom>
-          <a:solidFill>
-            <a:srgbClr val="FFFFFF">
-              <a:alpha val="92000"/>
-            </a:srgbClr>
-          </a:solidFill>
+            <a:off x="5669280" y="3474720"/>
+            <a:ext cx="960120" cy="282440"/>
+          </a:xfrm>
+          <a:prstGeom prst="rect">
+            <a:avLst/>
+          </a:prstGeom>
+          <a:noFill/>
           <a:ln/>
         </p:spPr>
         <p:txBody>
@@ -9194,7 +9182,7 @@
                 <a:ea typeface="Arial Unicode MS" pitchFamily="34" charset="-122"/>
                 <a:cs typeface="Arial Unicode MS" pitchFamily="34" charset="-120"/>
               </a:rPr>
-              <a:t>缺少安全边际</a:t>
+              <a:t>缺少收益余量</a:t>
             </a:r>
             <a:endParaRPr lang="en-US" sz="900" dirty="0"/>
           </a:p>

</xml_diff>